<commit_message>
Adopt CERN-OHL-P-2.0 hardware license
</commit_message>
<xml_diff>
--- a/Auto tea Steeper Design Overview.pptx
+++ b/Auto tea Steeper Design Overview.pptx
@@ -272,7 +272,7 @@
           <a:p>
             <a:fld id="{591D8B96-B175-4B12-A095-A7B54A04B3D1}" type="datetimeFigureOut">
               <a:rPr lang="en-US" smtClean="0"/>
-              <a:t>1/7/2026</a:t>
+              <a:t>10/5/2026</a:t>
             </a:fld>
             <a:endParaRPr lang="en-US"/>
           </a:p>
@@ -770,7 +770,7 @@
           <a:p>
             <a:fld id="{00A8F1EB-7B54-4224-9740-E381C9723DD6}" type="datetimeFigureOut">
               <a:rPr lang="en-US" smtClean="0"/>
-              <a:t>1/7/2026</a:t>
+              <a:t>10/5/2026</a:t>
             </a:fld>
             <a:endParaRPr lang="en-US"/>
           </a:p>
@@ -968,7 +968,7 @@
           <a:p>
             <a:fld id="{00A8F1EB-7B54-4224-9740-E381C9723DD6}" type="datetimeFigureOut">
               <a:rPr lang="en-US" smtClean="0"/>
-              <a:t>1/7/2026</a:t>
+              <a:t>10/5/2026</a:t>
             </a:fld>
             <a:endParaRPr lang="en-US"/>
           </a:p>
@@ -1176,7 +1176,7 @@
           <a:p>
             <a:fld id="{00A8F1EB-7B54-4224-9740-E381C9723DD6}" type="datetimeFigureOut">
               <a:rPr lang="en-US" smtClean="0"/>
-              <a:t>1/7/2026</a:t>
+              <a:t>10/5/2026</a:t>
             </a:fld>
             <a:endParaRPr lang="en-US"/>
           </a:p>
@@ -1374,7 +1374,7 @@
           <a:p>
             <a:fld id="{00A8F1EB-7B54-4224-9740-E381C9723DD6}" type="datetimeFigureOut">
               <a:rPr lang="en-US" smtClean="0"/>
-              <a:t>1/7/2026</a:t>
+              <a:t>10/5/2026</a:t>
             </a:fld>
             <a:endParaRPr lang="en-US"/>
           </a:p>
@@ -1649,7 +1649,7 @@
           <a:p>
             <a:fld id="{00A8F1EB-7B54-4224-9740-E381C9723DD6}" type="datetimeFigureOut">
               <a:rPr lang="en-US" smtClean="0"/>
-              <a:t>1/7/2026</a:t>
+              <a:t>10/5/2026</a:t>
             </a:fld>
             <a:endParaRPr lang="en-US"/>
           </a:p>
@@ -1914,7 +1914,7 @@
           <a:p>
             <a:fld id="{00A8F1EB-7B54-4224-9740-E381C9723DD6}" type="datetimeFigureOut">
               <a:rPr lang="en-US" smtClean="0"/>
-              <a:t>1/7/2026</a:t>
+              <a:t>10/5/2026</a:t>
             </a:fld>
             <a:endParaRPr lang="en-US"/>
           </a:p>
@@ -2326,7 +2326,7 @@
           <a:p>
             <a:fld id="{00A8F1EB-7B54-4224-9740-E381C9723DD6}" type="datetimeFigureOut">
               <a:rPr lang="en-US" smtClean="0"/>
-              <a:t>1/7/2026</a:t>
+              <a:t>10/5/2026</a:t>
             </a:fld>
             <a:endParaRPr lang="en-US"/>
           </a:p>
@@ -2467,7 +2467,7 @@
           <a:p>
             <a:fld id="{00A8F1EB-7B54-4224-9740-E381C9723DD6}" type="datetimeFigureOut">
               <a:rPr lang="en-US" smtClean="0"/>
-              <a:t>1/7/2026</a:t>
+              <a:t>10/5/2026</a:t>
             </a:fld>
             <a:endParaRPr lang="en-US"/>
           </a:p>
@@ -2580,7 +2580,7 @@
           <a:p>
             <a:fld id="{00A8F1EB-7B54-4224-9740-E381C9723DD6}" type="datetimeFigureOut">
               <a:rPr lang="en-US" smtClean="0"/>
-              <a:t>1/7/2026</a:t>
+              <a:t>10/5/2026</a:t>
             </a:fld>
             <a:endParaRPr lang="en-US"/>
           </a:p>
@@ -2891,7 +2891,7 @@
           <a:p>
             <a:fld id="{00A8F1EB-7B54-4224-9740-E381C9723DD6}" type="datetimeFigureOut">
               <a:rPr lang="en-US" smtClean="0"/>
-              <a:t>1/7/2026</a:t>
+              <a:t>10/5/2026</a:t>
             </a:fld>
             <a:endParaRPr lang="en-US"/>
           </a:p>
@@ -3179,7 +3179,7 @@
           <a:p>
             <a:fld id="{00A8F1EB-7B54-4224-9740-E381C9723DD6}" type="datetimeFigureOut">
               <a:rPr lang="en-US" smtClean="0"/>
-              <a:t>1/7/2026</a:t>
+              <a:t>10/5/2026</a:t>
             </a:fld>
             <a:endParaRPr lang="en-US"/>
           </a:p>
@@ -3420,7 +3420,7 @@
           <a:p>
             <a:fld id="{00A8F1EB-7B54-4224-9740-E381C9723DD6}" type="datetimeFigureOut">
               <a:rPr lang="en-US" smtClean="0"/>
-              <a:t>1/7/2026</a:t>
+              <a:t>10/5/2026</a:t>
             </a:fld>
             <a:endParaRPr lang="en-US"/>
           </a:p>
@@ -3898,37 +3898,6 @@
           <a:xfrm>
             <a:off x="3418522" y="1638300"/>
             <a:ext cx="4257675" cy="5219700"/>
-          </a:xfrm>
-          <a:prstGeom prst="rect">
-            <a:avLst/>
-          </a:prstGeom>
-        </p:spPr>
-      </p:pic>
-      <p:pic>
-        <p:nvPicPr>
-          <p:cNvPr id="6" name="Picture 5">
-            <a:hlinkClick r:id="rId3"/>
-            <a:extLst>
-              <a:ext uri="{FF2B5EF4-FFF2-40B4-BE49-F238E27FC236}">
-                <a16:creationId xmlns:a16="http://schemas.microsoft.com/office/drawing/2014/main" id="{4DACF185-F5A4-F243-E906-F65ECDF9BA1F}"/>
-              </a:ext>
-            </a:extLst>
-          </p:cNvPr>
-          <p:cNvPicPr>
-            <a:picLocks noChangeAspect="1"/>
-          </p:cNvPicPr>
-          <p:nvPr/>
-        </p:nvPicPr>
-        <p:blipFill>
-          <a:blip r:embed="rId4"/>
-          <a:stretch>
-            <a:fillRect/>
-          </a:stretch>
-        </p:blipFill>
-        <p:spPr>
-          <a:xfrm>
-            <a:off x="10824987" y="6226629"/>
-            <a:ext cx="1265912" cy="442912"/>
           </a:xfrm>
           <a:prstGeom prst="rect">
             <a:avLst/>

</xml_diff>